<commit_message>
fixed nav and margins for consistency
</commit_message>
<xml_diff>
--- a/airc-sss/The_Persistence_Imperative.pptx
+++ b/airc-sss/The_Persistence_Imperative.pptx
@@ -5747,7 +5747,7 @@
                 <a:ea typeface="Calibri" pitchFamily="34" charset="-122"/>
                 <a:cs typeface="Calibri" pitchFamily="34" charset="-120"/>
               </a:rPr>
-              <a:t>face food or housing insecurity (44% at GCC).</a:t>
+              <a:t>face food or housing insecurity.</a:t>
             </a:r>
             <a:endParaRPr lang="en-US" sz="1200" dirty="0"/>
           </a:p>
@@ -5786,7 +5786,7 @@
                 <a:ea typeface="Calibri" pitchFamily="34" charset="-122"/>
                 <a:cs typeface="Calibri" pitchFamily="34" charset="-120"/>
               </a:rPr>
-              <a:t>Hope Center · GCC</a:t>
+              <a:t>Hope Center</a:t>
             </a:r>
             <a:endParaRPr lang="en-US" sz="800" dirty="0"/>
           </a:p>
@@ -6285,7 +6285,7 @@
                 <a:ea typeface="Georgia" pitchFamily="34" charset="-122"/>
                 <a:cs typeface="Georgia" pitchFamily="34" charset="-120"/>
               </a:rPr>
-              <a:t>These are not edge cases; they are the modal experience of the community college student. GCC is a Hispanic-Serving Institution, 43% Hispanic, as are nine of the ten Maricopa colleges, where extended-family caregiving for siblings, parents, and ill relatives reaches well beyond the one in five who are parents.</a:t>
+              <a:t>These are not edge cases; they are the modal experience of the community college student. Nine of the ten Maricopa colleges are Hispanic-Serving Institutions, where extended-family caregiving for siblings, parents, and ill relatives reaches well beyond the one in five who are parents.</a:t>
             </a:r>
             <a:endParaRPr lang="en-US" sz="1350" dirty="0"/>
           </a:p>
@@ -9626,7 +9626,7 @@
                 <a:ea typeface="Calibri" pitchFamily="34" charset="-122"/>
                 <a:cs typeface="Calibri" pitchFamily="34" charset="-120"/>
               </a:rPr>
-              <a:t>The food pantry, emergency funds, and campus social workers: GCC’s Basic Needs program.</a:t>
+              <a:t>The food pantry, emergency funds, and campus social workers: our Basic Needs programs.</a:t>
             </a:r>
             <a:endParaRPr lang="en-US" sz="1200" dirty="0"/>
           </a:p>

</xml_diff>